<commit_message>
Version del 14 de mayo 10h20
Version con los cambios finales
</commit_message>
<xml_diff>
--- a/presentacion/UEES Aprendizaje Automatica - Semana 3 Actividad 1.pptx
+++ b/presentacion/UEES Aprendizaje Automatica - Semana 3 Actividad 1.pptx
@@ -596,7 +596,7 @@
             <a:pPr rtl="0"/>
             <a:fld id="{F6DAC6D3-CBD9-4093-ACF2-8A12DA24A989}" type="datetime1">
               <a:rPr lang="es-ES" smtClean="0"/>
-              <a:t>13/05/2026</a:t>
+              <a:t>14/05/2026</a:t>
             </a:fld>
             <a:endParaRPr lang="es-ES"/>
           </a:p>
@@ -778,7 +778,7 @@
             <a:pPr rtl="0"/>
             <a:fld id="{9B7CF384-A5AD-45CE-8435-F14E9527E3A8}" type="datetime1">
               <a:rPr lang="es-ES" noProof="0" smtClean="0"/>
-              <a:t>13/05/2026</a:t>
+              <a:t>14/05/2026</a:t>
             </a:fld>
             <a:endParaRPr lang="es-ES" noProof="0"/>
           </a:p>
@@ -2246,7 +2246,7 @@
           </a:effectLst>
           <a:extLst>
             <a:ext uri="{91240B29-F687-4f45-9708-019B960494DF}">
-              <a14:hiddenLine xmlns:a14="http://schemas.microsoft.com/office/drawing/2010/main" xmlns="" w="9525">
+              <a14:hiddenLine xmlns="" xmlns:a14="http://schemas.microsoft.com/office/drawing/2010/main" w="9525">
                 <a:solidFill>
                   <a:srgbClr val="000000"/>
                 </a:solidFill>
@@ -2448,7 +2448,7 @@
             <a:pPr rtl="0"/>
             <a:fld id="{D6AEAB7B-E6F9-4422-A438-2E4071AEDF32}" type="datetime1">
               <a:rPr lang="es-ES" noProof="0" smtClean="0"/>
-              <a:t>13/05/2026</a:t>
+              <a:t>14/05/2026</a:t>
             </a:fld>
             <a:endParaRPr lang="es-ES" noProof="0"/>
           </a:p>
@@ -2810,7 +2810,7 @@
             <a:pPr rtl="0"/>
             <a:fld id="{C9CF8050-D9B5-4CA7-9061-E0949EF45D2D}" type="datetime1">
               <a:rPr lang="es-ES" noProof="0" smtClean="0"/>
-              <a:t>13/05/2026</a:t>
+              <a:t>14/05/2026</a:t>
             </a:fld>
             <a:endParaRPr lang="es-ES" noProof="0"/>
           </a:p>
@@ -2989,7 +2989,7 @@
           </a:effectLst>
           <a:extLst>
             <a:ext uri="{91240B29-F687-4f45-9708-019B960494DF}">
-              <a14:hiddenLine xmlns:a14="http://schemas.microsoft.com/office/drawing/2010/main" xmlns="" w="9525">
+              <a14:hiddenLine xmlns="" xmlns:a14="http://schemas.microsoft.com/office/drawing/2010/main" w="9525">
                 <a:solidFill>
                   <a:srgbClr val="000000"/>
                 </a:solidFill>
@@ -3316,7 +3316,7 @@
             <a:pPr rtl="0"/>
             <a:fld id="{66ECA3B6-4A2A-4A99-9E95-BC8EA8654457}" type="datetime1">
               <a:rPr lang="es-ES" noProof="0" smtClean="0"/>
-              <a:t>13/05/2026</a:t>
+              <a:t>14/05/2026</a:t>
             </a:fld>
             <a:endParaRPr lang="es-ES" noProof="0"/>
           </a:p>
@@ -3495,7 +3495,7 @@
           </a:effectLst>
           <a:extLst>
             <a:ext uri="{91240B29-F687-4f45-9708-019B960494DF}">
-              <a14:hiddenLine xmlns:a14="http://schemas.microsoft.com/office/drawing/2010/main" xmlns="" w="9525">
+              <a14:hiddenLine xmlns="" xmlns:a14="http://schemas.microsoft.com/office/drawing/2010/main" w="9525">
                 <a:solidFill>
                   <a:srgbClr val="000000"/>
                 </a:solidFill>
@@ -3579,7 +3579,7 @@
             <a:pPr rtl="0"/>
             <a:fld id="{E9BDD705-EE32-4D72-AA0A-3DFA22B87416}" type="datetime1">
               <a:rPr lang="es-ES" noProof="0" smtClean="0"/>
-              <a:t>13/05/2026</a:t>
+              <a:t>14/05/2026</a:t>
             </a:fld>
             <a:endParaRPr lang="es-ES" noProof="0"/>
           </a:p>
@@ -3698,7 +3698,7 @@
             <a:pPr rtl="0"/>
             <a:fld id="{28D43FF9-1FDC-4FDF-B4FB-CA915895770E}" type="datetime1">
               <a:rPr lang="es-ES" noProof="0" smtClean="0"/>
-              <a:t>13/05/2026</a:t>
+              <a:t>14/05/2026</a:t>
             </a:fld>
             <a:endParaRPr lang="es-ES" noProof="0"/>
           </a:p>
@@ -3988,7 +3988,7 @@
           </a:effectLst>
           <a:extLst>
             <a:ext uri="{91240B29-F687-4f45-9708-019B960494DF}">
-              <a14:hiddenLine xmlns:a14="http://schemas.microsoft.com/office/drawing/2010/main" xmlns="" w="9525">
+              <a14:hiddenLine xmlns="" xmlns:a14="http://schemas.microsoft.com/office/drawing/2010/main" w="9525">
                 <a:solidFill>
                   <a:srgbClr val="000000"/>
                 </a:solidFill>
@@ -4195,7 +4195,7 @@
             <a:pPr rtl="0"/>
             <a:fld id="{C2A648A3-3014-4E79-9B72-A0D270E334FA}" type="datetime1">
               <a:rPr lang="es-ES" noProof="0" smtClean="0"/>
-              <a:t>13/05/2026</a:t>
+              <a:t>14/05/2026</a:t>
             </a:fld>
             <a:endParaRPr lang="es-ES" noProof="0"/>
           </a:p>
@@ -4714,7 +4714,7 @@
             <a:pPr rtl="0"/>
             <a:fld id="{8F2636EF-ACE9-4CE0-BBE7-61EEDEF2D8A4}" type="datetime1">
               <a:rPr lang="es-ES" noProof="0" smtClean="0"/>
-              <a:t>13/05/2026</a:t>
+              <a:t>14/05/2026</a:t>
             </a:fld>
             <a:endParaRPr lang="es-ES" noProof="0"/>
           </a:p>
@@ -5114,7 +5114,7 @@
             <a:pPr rtl="0"/>
             <a:fld id="{82403D32-1036-4E20-B05E-93A4B3F27179}" type="datetime1">
               <a:rPr lang="es-ES" noProof="0" smtClean="0"/>
-              <a:t>13/05/2026</a:t>
+              <a:t>14/05/2026</a:t>
             </a:fld>
             <a:endParaRPr lang="es-ES" noProof="0"/>
           </a:p>
@@ -5295,7 +5295,7 @@
           </a:effectLst>
           <a:extLst>
             <a:ext uri="{91240B29-F687-4f45-9708-019B960494DF}">
-              <a14:hiddenLine xmlns:a14="http://schemas.microsoft.com/office/drawing/2010/main" xmlns="" w="9525">
+              <a14:hiddenLine xmlns="" xmlns:a14="http://schemas.microsoft.com/office/drawing/2010/main" w="9525">
                 <a:solidFill>
                   <a:srgbClr val="000000"/>
                 </a:solidFill>
@@ -5449,7 +5449,7 @@
             <a:pPr rtl="0"/>
             <a:fld id="{FAED9500-2405-4E53-BB13-657A10319D0C}" type="datetime1">
               <a:rPr lang="es-ES" noProof="0" smtClean="0"/>
-              <a:t>13/05/2026</a:t>
+              <a:t>14/05/2026</a:t>
             </a:fld>
             <a:endParaRPr lang="es-ES" noProof="0"/>
           </a:p>
@@ -5628,7 +5628,7 @@
           </a:effectLst>
           <a:extLst>
             <a:ext uri="{91240B29-F687-4f45-9708-019B960494DF}">
-              <a14:hiddenLine xmlns:a14="http://schemas.microsoft.com/office/drawing/2010/main" xmlns="" w="9525">
+              <a14:hiddenLine xmlns="" xmlns:a14="http://schemas.microsoft.com/office/drawing/2010/main" w="9525">
                 <a:solidFill>
                   <a:srgbClr val="000000"/>
                 </a:solidFill>
@@ -5856,7 +5856,7 @@
             <a:pPr rtl="0"/>
             <a:fld id="{67D6D300-52EA-41C5-9D55-44B950D4BB30}" type="datetime1">
               <a:rPr lang="es-ES" noProof="0" smtClean="0"/>
-              <a:t>13/05/2026</a:t>
+              <a:t>14/05/2026</a:t>
             </a:fld>
             <a:endParaRPr lang="es-ES" noProof="0"/>
           </a:p>
@@ -6118,7 +6118,7 @@
             <a:pPr rtl="0"/>
             <a:fld id="{3F23C61D-72BC-4EDD-9458-71D395860092}" type="datetime1">
               <a:rPr lang="es-ES" noProof="0" smtClean="0"/>
-              <a:t>13/05/2026</a:t>
+              <a:t>14/05/2026</a:t>
             </a:fld>
             <a:endParaRPr lang="es-ES" noProof="0"/>
           </a:p>
@@ -6297,7 +6297,7 @@
           </a:effectLst>
           <a:extLst>
             <a:ext uri="{91240B29-F687-4f45-9708-019B960494DF}">
-              <a14:hiddenLine xmlns:a14="http://schemas.microsoft.com/office/drawing/2010/main" xmlns="" w="9525">
+              <a14:hiddenLine xmlns="" xmlns:a14="http://schemas.microsoft.com/office/drawing/2010/main" w="9525">
                 <a:solidFill>
                   <a:srgbClr val="000000"/>
                 </a:solidFill>
@@ -6547,7 +6547,7 @@
             <a:pPr rtl="0"/>
             <a:fld id="{86658110-F671-41DB-9A71-89FB238DCBEA}" type="datetime1">
               <a:rPr lang="es-ES" noProof="0" smtClean="0"/>
-              <a:t>13/05/2026</a:t>
+              <a:t>14/05/2026</a:t>
             </a:fld>
             <a:endParaRPr lang="es-ES" noProof="0"/>
           </a:p>
@@ -6726,7 +6726,7 @@
           </a:effectLst>
           <a:extLst>
             <a:ext uri="{91240B29-F687-4f45-9708-019B960494DF}">
-              <a14:hiddenLine xmlns:a14="http://schemas.microsoft.com/office/drawing/2010/main" xmlns="" w="9525">
+              <a14:hiddenLine xmlns="" xmlns:a14="http://schemas.microsoft.com/office/drawing/2010/main" w="9525">
                 <a:solidFill>
                   <a:srgbClr val="000000"/>
                 </a:solidFill>
@@ -6970,7 +6970,7 @@
             <a:pPr rtl="0"/>
             <a:fld id="{3FA16780-EC07-4193-A0B7-8B9C634C5917}" type="datetime1">
               <a:rPr lang="es-ES" noProof="0" smtClean="0"/>
-              <a:t>13/05/2026</a:t>
+              <a:t>14/05/2026</a:t>
             </a:fld>
             <a:endParaRPr lang="es-ES" noProof="0"/>
           </a:p>
@@ -7396,7 +7396,7 @@
             <a:pPr rtl="0"/>
             <a:fld id="{8C701FF8-D49B-4CFB-997D-DF23AD6F99CE}" type="datetime1">
               <a:rPr lang="es-ES" noProof="0" smtClean="0"/>
-              <a:t>13/05/2026</a:t>
+              <a:t>14/05/2026</a:t>
             </a:fld>
             <a:endParaRPr lang="es-ES" noProof="0"/>
           </a:p>
@@ -7575,7 +7575,7 @@
           </a:effectLst>
           <a:extLst>
             <a:ext uri="{91240B29-F687-4f45-9708-019B960494DF}">
-              <a14:hiddenLine xmlns:a14="http://schemas.microsoft.com/office/drawing/2010/main" xmlns="" w="9525">
+              <a14:hiddenLine xmlns="" xmlns:a14="http://schemas.microsoft.com/office/drawing/2010/main" w="9525">
                 <a:solidFill>
                   <a:srgbClr val="000000"/>
                 </a:solidFill>
@@ -7733,7 +7733,7 @@
             <a:pPr rtl="0"/>
             <a:fld id="{48ED49E0-4367-45F3-89AF-A0AB892FB1D9}" type="datetime1">
               <a:rPr lang="es-ES" noProof="0" smtClean="0"/>
-              <a:t>13/05/2026</a:t>
+              <a:t>14/05/2026</a:t>
             </a:fld>
             <a:endParaRPr lang="es-ES" noProof="0"/>
           </a:p>
@@ -8300,7 +8300,7 @@
             <a:pPr rtl="0"/>
             <a:fld id="{DAC8E451-8F0D-4243-9BCB-F9C29FEF97FB}" type="datetime1">
               <a:rPr lang="es-ES" noProof="0" smtClean="0"/>
-              <a:t>13/05/2026</a:t>
+              <a:t>14/05/2026</a:t>
             </a:fld>
             <a:endParaRPr lang="es-ES" noProof="0"/>
           </a:p>
@@ -8479,7 +8479,7 @@
           </a:effectLst>
           <a:extLst>
             <a:ext uri="{91240B29-F687-4f45-9708-019B960494DF}">
-              <a14:hiddenLine xmlns:a14="http://schemas.microsoft.com/office/drawing/2010/main" xmlns="" w="9525">
+              <a14:hiddenLine xmlns="" xmlns:a14="http://schemas.microsoft.com/office/drawing/2010/main" w="9525">
                 <a:solidFill>
                   <a:srgbClr val="000000"/>
                 </a:solidFill>
@@ -8617,7 +8617,7 @@
             <a:pPr rtl="0"/>
             <a:fld id="{0904AF0A-3AF9-49F1-BA72-97A8E09ABF33}" type="datetime1">
               <a:rPr lang="es-ES" noProof="0" smtClean="0"/>
-              <a:t>13/05/2026</a:t>
+              <a:t>14/05/2026</a:t>
             </a:fld>
             <a:endParaRPr lang="es-ES" noProof="0"/>
           </a:p>
@@ -8886,7 +8886,7 @@
             <a:pPr rtl="0"/>
             <a:fld id="{8BD1572E-1521-478D-85F1-7F19532C7538}" type="datetime1">
               <a:rPr lang="es-ES" noProof="0" smtClean="0"/>
-              <a:t>13/05/2026</a:t>
+              <a:t>14/05/2026</a:t>
             </a:fld>
             <a:endParaRPr lang="es-ES" noProof="0"/>
           </a:p>
@@ -9500,31 +9500,36 @@
             <p:ph sz="half" idx="2"/>
           </p:nvPr>
         </p:nvSpPr>
-        <p:spPr/>
+        <p:spPr>
+          <a:xfrm>
+            <a:off x="810001" y="2222286"/>
+            <a:ext cx="10571998" cy="4635713"/>
+          </a:xfrm>
+        </p:spPr>
         <p:txBody>
           <a:bodyPr>
-            <a:normAutofit fontScale="70000" lnSpcReduction="20000"/>
+            <a:normAutofit fontScale="85000" lnSpcReduction="20000"/>
           </a:bodyPr>
           <a:lstStyle/>
           <a:p>
             <a:pPr algn="just"/>
             <a:r>
               <a:rPr lang="es-MX" dirty="0"/>
-              <a:t>Las técnicas de aprendizaje no supervisado permitieron identificar diferentes perfiles estudiantiles.</a:t>
+              <a:t>Las técnicas de aprendizaje no supervisado permitieron identificar diferentes perfiles estudiantiles. </a:t>
             </a:r>
           </a:p>
           <a:p>
             <a:pPr algn="just"/>
             <a:r>
               <a:rPr lang="es-MX" dirty="0"/>
-              <a:t>Las horas de estudio y el rendimiento académico mostraron relaciones importantes dentro del análisis.</a:t>
+              <a:t>Las horas de estudio, la asistencia y el rendimiento académico mostraron relaciones importantes dentro del análisis. </a:t>
             </a:r>
           </a:p>
           <a:p>
             <a:pPr algn="just"/>
             <a:r>
               <a:rPr lang="es-MX" dirty="0"/>
-              <a:t>K-Means generó </a:t>
+              <a:t>K-Means permitió obtener </a:t>
             </a:r>
             <a:r>
               <a:rPr lang="es-MX" dirty="0" err="1"/>
@@ -9532,29 +9537,21 @@
             </a:r>
             <a:r>
               <a:rPr lang="es-MX" dirty="0"/>
-              <a:t> más interpretables y balanceados para este </a:t>
-            </a:r>
-            <a:r>
-              <a:rPr lang="es-MX" dirty="0" err="1"/>
-              <a:t>dataset</a:t>
-            </a:r>
+              <a:t> interpretables para el análisis de perfiles estudiantiles. </a:t>
+            </a:r>
+          </a:p>
+          <a:p>
+            <a:pPr algn="just"/>
             <a:r>
               <a:rPr lang="es-MX" dirty="0"/>
-              <a:t>.</a:t>
+              <a:t>DBSCAN permitió detectar agrupamientos por densidad y posibles observaciones atípicas. </a:t>
             </a:r>
           </a:p>
           <a:p>
             <a:pPr algn="just"/>
             <a:r>
               <a:rPr lang="es-MX" dirty="0"/>
-              <a:t>DBSCAN permitió detectar agrupamientos por densidad y posibles observaciones atípicas.</a:t>
-            </a:r>
-          </a:p>
-          <a:p>
-            <a:pPr algn="just"/>
-            <a:r>
-              <a:rPr lang="es-MX" dirty="0"/>
-              <a:t>PCA y t-SNE facilitaron la visualización y comprensión de patrones complejos.</a:t>
+              <a:t>PCA y t-SNE facilitaron la visualización de patrones y agrupamientos complejos en los datos. </a:t>
             </a:r>
           </a:p>
           <a:p>
@@ -10374,11 +10371,11 @@
         </p:spPr>
         <p:txBody>
           <a:bodyPr>
-            <a:normAutofit fontScale="55000" lnSpcReduction="20000"/>
+            <a:normAutofit fontScale="62500" lnSpcReduction="20000"/>
           </a:bodyPr>
           <a:lstStyle/>
           <a:p>
-            <a:pPr marL="0" indent="0">
+            <a:pPr marL="0" indent="0" algn="just">
               <a:buNone/>
             </a:pPr>
             <a:r>
@@ -10387,57 +10384,61 @@
             </a:r>
           </a:p>
           <a:p>
+            <a:pPr algn="just"/>
             <a:endParaRPr lang="es-MX" dirty="0"/>
           </a:p>
           <a:p>
+            <a:pPr algn="just"/>
             <a:r>
               <a:rPr lang="es-MX" dirty="0"/>
               <a:t>Las horas de estudio mostraron una fuerte relación con el rendimiento académico.</a:t>
             </a:r>
           </a:p>
           <a:p>
-            <a:endParaRPr lang="es-MX" dirty="0"/>
-          </a:p>
-          <a:p>
+            <a:pPr algn="just"/>
             <a:r>
               <a:rPr lang="es-MX" dirty="0"/>
-              <a:t>La asistencia presentó una correlación moderada con las calificaciones finales.</a:t>
-            </a:r>
-          </a:p>
-          <a:p>
-            <a:endParaRPr lang="es-MX" dirty="0"/>
-          </a:p>
-          <a:p>
+              <a:t>La asistencia presentó una relación positiva moderada con las calificaciones finales.</a:t>
+            </a:r>
+          </a:p>
+          <a:p>
+            <a:pPr algn="just"/>
             <a:r>
               <a:rPr lang="es-MX" dirty="0"/>
-              <a:t>Se identificaron patrones diferenciados entre estudiantes según hábitos de estudio y desempeño.</a:t>
-            </a:r>
-          </a:p>
-          <a:p>
-            <a:endParaRPr lang="es-MX" dirty="0"/>
-          </a:p>
-          <a:p>
-            <a:pPr marL="0" indent="0">
+              <a:t>Se identificaron patrones diferenciados entre estudiantes según horas de estudio, asistencia y rendimiento académico.</a:t>
+            </a:r>
+          </a:p>
+          <a:p>
+            <a:pPr marL="0" indent="0" algn="just">
               <a:buNone/>
             </a:pPr>
+            <a:endParaRPr lang="es-MX" dirty="0"/>
+          </a:p>
+          <a:p>
+            <a:pPr marL="0" indent="0" algn="just">
+              <a:buNone/>
+            </a:pPr>
             <a:r>
               <a:rPr lang="es-MX" dirty="0"/>
               <a:t>Visualizaciones realizadas:</a:t>
             </a:r>
           </a:p>
           <a:p>
+            <a:pPr algn="just"/>
             <a:r>
               <a:rPr lang="es-MX" dirty="0"/>
               <a:t>Matriz de correlación</a:t>
             </a:r>
           </a:p>
           <a:p>
+            <a:pPr algn="just"/>
             <a:r>
               <a:rPr lang="es-MX" dirty="0"/>
               <a:t>Histogramas de distribución</a:t>
             </a:r>
           </a:p>
           <a:p>
+            <a:pPr algn="just"/>
             <a:r>
               <a:rPr lang="es-MX" dirty="0"/>
               <a:t>Estadísticas descriptivas</a:t>
@@ -10448,10 +10449,10 @@
       </p:sp>
       <p:pic>
         <p:nvPicPr>
-          <p:cNvPr id="7" name="Imagen 6">
+          <p:cNvPr id="3" name="Imagen 2">
             <a:extLst>
               <a:ext uri="{FF2B5EF4-FFF2-40B4-BE49-F238E27FC236}">
-                <a16:creationId xmlns:a16="http://schemas.microsoft.com/office/drawing/2014/main" id="{DCDBCF10-E0B0-DF09-AD35-7036FD2531DF}"/>
+                <a16:creationId xmlns:a16="http://schemas.microsoft.com/office/drawing/2014/main" id="{7438101D-A3FC-624A-9CC9-12B96F17D3F6}"/>
               </a:ext>
             </a:extLst>
           </p:cNvPr>
@@ -10468,8 +10469,8 @@
         </p:blipFill>
         <p:spPr>
           <a:xfrm>
-            <a:off x="5969277" y="1915867"/>
-            <a:ext cx="6222723" cy="4813706"/>
+            <a:off x="6500124" y="2053184"/>
+            <a:ext cx="5498367" cy="4804815"/>
           </a:xfrm>
           <a:prstGeom prst="rect">
             <a:avLst/>
@@ -10565,11 +10566,11 @@
         </p:spPr>
         <p:txBody>
           <a:bodyPr>
-            <a:normAutofit fontScale="62500" lnSpcReduction="20000"/>
+            <a:normAutofit fontScale="55000" lnSpcReduction="20000"/>
           </a:bodyPr>
           <a:lstStyle/>
           <a:p>
-            <a:pPr marL="0" indent="0">
+            <a:pPr marL="0" indent="0" algn="just">
               <a:buNone/>
             </a:pPr>
             <a:r>
@@ -10578,16 +10579,18 @@
             </a:r>
           </a:p>
           <a:p>
+            <a:pPr algn="just"/>
             <a:r>
               <a:rPr lang="es-MX" dirty="0"/>
               <a:t>Identificar agrupamientos de estudiantes con características similares.</a:t>
             </a:r>
           </a:p>
           <a:p>
+            <a:pPr algn="just"/>
             <a:endParaRPr lang="es-MX" dirty="0"/>
           </a:p>
           <a:p>
-            <a:pPr marL="0" indent="0">
+            <a:pPr marL="0" indent="0" algn="just">
               <a:buNone/>
             </a:pPr>
             <a:r>
@@ -10596,6 +10599,7 @@
             </a:r>
           </a:p>
           <a:p>
+            <a:pPr algn="just"/>
             <a:r>
               <a:rPr lang="es-MX" dirty="0" err="1"/>
               <a:t>Elbow</a:t>
@@ -10606,6 +10610,7 @@
             </a:r>
           </a:p>
           <a:p>
+            <a:pPr algn="just"/>
             <a:r>
               <a:rPr lang="es-MX" dirty="0" err="1"/>
               <a:t>Silhouette</a:t>
@@ -10616,10 +10621,11 @@
             </a:r>
           </a:p>
           <a:p>
+            <a:pPr algn="just"/>
             <a:endParaRPr lang="es-MX" dirty="0"/>
           </a:p>
           <a:p>
-            <a:pPr marL="0" indent="0">
+            <a:pPr marL="0" indent="0" algn="just">
               <a:buNone/>
             </a:pPr>
             <a:r>
@@ -10628,9 +10634,10 @@
             </a:r>
           </a:p>
           <a:p>
+            <a:pPr algn="just"/>
             <a:r>
               <a:rPr lang="es-MX" dirty="0"/>
-              <a:t>Se seleccionaron 4 </a:t>
+              <a:t>Se trabajó con 4 </a:t>
             </a:r>
             <a:r>
               <a:rPr lang="es-MX" dirty="0" err="1"/>
@@ -10638,16 +10645,18 @@
             </a:r>
             <a:r>
               <a:rPr lang="es-MX" dirty="0"/>
-              <a:t>.</a:t>
-            </a:r>
-          </a:p>
-          <a:p>
+              <a:t> para obtener una segmentación más interpretable de los perfiles estudiantiles.</a:t>
+            </a:r>
+          </a:p>
+          <a:p>
+            <a:pPr algn="just"/>
             <a:r>
               <a:rPr lang="es-MX" dirty="0"/>
               <a:t>Se obtuvieron agrupamientos relativamente balanceados.</a:t>
             </a:r>
           </a:p>
           <a:p>
+            <a:pPr algn="just"/>
             <a:r>
               <a:rPr lang="es-MX" dirty="0"/>
               <a:t>Los </a:t>
@@ -10658,7 +10667,7 @@
             </a:r>
             <a:r>
               <a:rPr lang="es-MX" dirty="0"/>
-              <a:t> mostraron diferencias en hábitos de estudio y rendimiento académico.</a:t>
+              <a:t> mostraron diferencias en horas de estudio, asistencia y rendimiento académico.</a:t>
             </a:r>
             <a:endParaRPr lang="es-EC" dirty="0"/>
           </a:p>
@@ -10666,10 +10675,10 @@
       </p:sp>
       <p:pic>
         <p:nvPicPr>
-          <p:cNvPr id="7" name="Imagen 6">
+          <p:cNvPr id="3" name="Imagen 2">
             <a:extLst>
               <a:ext uri="{FF2B5EF4-FFF2-40B4-BE49-F238E27FC236}">
-                <a16:creationId xmlns:a16="http://schemas.microsoft.com/office/drawing/2014/main" id="{C07FBF6E-0A71-CD03-640E-F1A017BCC15C}"/>
+                <a16:creationId xmlns:a16="http://schemas.microsoft.com/office/drawing/2014/main" id="{FEE2079A-0C28-483D-6808-530379BC3EA3}"/>
               </a:ext>
             </a:extLst>
           </p:cNvPr>
@@ -10686,8 +10695,8 @@
         </p:blipFill>
         <p:spPr>
           <a:xfrm>
-            <a:off x="5440459" y="2001136"/>
-            <a:ext cx="3496315" cy="2622236"/>
+            <a:off x="5256992" y="1922726"/>
+            <a:ext cx="3496315" cy="2742798"/>
           </a:xfrm>
           <a:prstGeom prst="rect">
             <a:avLst/>
@@ -10696,10 +10705,10 @@
       </p:pic>
       <p:pic>
         <p:nvPicPr>
-          <p:cNvPr id="8" name="Imagen 7">
+          <p:cNvPr id="4" name="Imagen 3">
             <a:extLst>
               <a:ext uri="{FF2B5EF4-FFF2-40B4-BE49-F238E27FC236}">
-                <a16:creationId xmlns:a16="http://schemas.microsoft.com/office/drawing/2014/main" id="{7B9E37C4-E3D2-DBC5-7C58-F1D1EF0060F3}"/>
+                <a16:creationId xmlns:a16="http://schemas.microsoft.com/office/drawing/2014/main" id="{87DF24F0-EA41-8EDC-62FB-F3BF799F7FC5}"/>
               </a:ext>
             </a:extLst>
           </p:cNvPr>
@@ -10716,8 +10725,8 @@
         </p:blipFill>
         <p:spPr>
           <a:xfrm>
-            <a:off x="8594601" y="4096154"/>
-            <a:ext cx="3496315" cy="2761846"/>
+            <a:off x="8753306" y="4029458"/>
+            <a:ext cx="3438693" cy="2716329"/>
           </a:xfrm>
           <a:prstGeom prst="rect">
             <a:avLst/>
@@ -10807,8 +10816,8 @@
         </p:nvSpPr>
         <p:spPr>
           <a:xfrm>
-            <a:off x="810001" y="2222286"/>
-            <a:ext cx="5529827" cy="4558657"/>
+            <a:off x="306043" y="1795550"/>
+            <a:ext cx="6395258" cy="4985394"/>
           </a:xfrm>
         </p:spPr>
         <p:txBody>
@@ -10908,21 +10917,13 @@
           <a:p>
             <a:r>
               <a:rPr lang="es-MX" dirty="0"/>
-              <a:t>DBSCAN identificó </a:t>
-            </a:r>
-            <a:r>
-              <a:rPr lang="es-MX" dirty="0" err="1"/>
-              <a:t>clusters</a:t>
-            </a:r>
+              <a:t>DBSCAN identificó agrupamientos basados en densidad y detectó observaciones atípicas.</a:t>
+            </a:r>
+          </a:p>
+          <a:p>
             <a:r>
               <a:rPr lang="es-MX" dirty="0"/>
-              <a:t> según zonas de mayor densidad.</a:t>
-            </a:r>
-          </a:p>
-          <a:p>
-            <a:r>
-              <a:rPr lang="es-MX" dirty="0"/>
-              <a:t>Los puntos con etiqueta -1 fueron considerados ruido o atípicos.</a:t>
+              <a:t>Los puntos con etiqueta -1 fueron clasificados como ruido u observaciones atípicas.</a:t>
             </a:r>
           </a:p>
           <a:p>
@@ -10970,10 +10971,10 @@
       </p:sp>
       <p:pic>
         <p:nvPicPr>
-          <p:cNvPr id="7" name="Imagen 6">
+          <p:cNvPr id="3" name="Imagen 2">
             <a:extLst>
               <a:ext uri="{FF2B5EF4-FFF2-40B4-BE49-F238E27FC236}">
-                <a16:creationId xmlns:a16="http://schemas.microsoft.com/office/drawing/2014/main" id="{3BF6EB5B-D1BD-82F6-FC48-7C2225732646}"/>
+                <a16:creationId xmlns:a16="http://schemas.microsoft.com/office/drawing/2014/main" id="{03802A68-E8CD-0B6A-1F9E-506D02673900}"/>
               </a:ext>
             </a:extLst>
           </p:cNvPr>
@@ -10990,8 +10991,8 @@
         </p:blipFill>
         <p:spPr>
           <a:xfrm>
-            <a:off x="6339828" y="2276571"/>
-            <a:ext cx="5852172" cy="4389129"/>
+            <a:off x="6701300" y="2421350"/>
+            <a:ext cx="5184658" cy="4160528"/>
           </a:xfrm>
           <a:prstGeom prst="rect">
             <a:avLst/>
@@ -11084,14 +11085,19 @@
             <p:ph sz="half" idx="2"/>
           </p:nvPr>
         </p:nvSpPr>
-        <p:spPr/>
+        <p:spPr>
+          <a:xfrm>
+            <a:off x="332509" y="2222287"/>
+            <a:ext cx="7535299" cy="4571692"/>
+          </a:xfrm>
+        </p:spPr>
         <p:txBody>
           <a:bodyPr>
-            <a:normAutofit fontScale="70000" lnSpcReduction="20000"/>
+            <a:normAutofit fontScale="62500" lnSpcReduction="20000"/>
           </a:bodyPr>
           <a:lstStyle/>
           <a:p>
-            <a:pPr marL="0" indent="0">
+            <a:pPr marL="0" indent="0" algn="just">
               <a:buNone/>
             </a:pPr>
             <a:r>
@@ -11100,12 +11106,14 @@
             </a:r>
           </a:p>
           <a:p>
+            <a:pPr algn="just"/>
             <a:r>
               <a:rPr lang="es-MX" dirty="0"/>
               <a:t>Reduce las variables a componentes principales.</a:t>
             </a:r>
           </a:p>
           <a:p>
+            <a:pPr algn="just"/>
             <a:r>
               <a:rPr lang="es-MX" dirty="0"/>
               <a:t>Permite visualizar los </a:t>
@@ -11120,16 +11128,14 @@
             </a:r>
           </a:p>
           <a:p>
+            <a:pPr algn="just"/>
             <a:r>
               <a:rPr lang="es-MX" dirty="0"/>
-              <a:t>Ayuda a interpretar la variabilidad de los datos.</a:t>
-            </a:r>
-          </a:p>
-          <a:p>
-            <a:endParaRPr lang="es-MX" dirty="0"/>
-          </a:p>
-          <a:p>
-            <a:pPr marL="0" indent="0">
+              <a:t>Permite conservar y visualizar gran parte de la variabilidad de los datos en 2 dimensiones.</a:t>
+            </a:r>
+          </a:p>
+          <a:p>
+            <a:pPr marL="0" indent="0" algn="just">
               <a:buNone/>
             </a:pPr>
             <a:r>
@@ -11138,32 +11144,48 @@
             </a:r>
           </a:p>
           <a:p>
+            <a:pPr algn="just"/>
             <a:r>
               <a:rPr lang="es-MX" dirty="0"/>
               <a:t>Permite visualizar patrones no lineales.</a:t>
             </a:r>
           </a:p>
           <a:p>
+            <a:pPr algn="just"/>
             <a:r>
               <a:rPr lang="es-MX" dirty="0"/>
-              <a:t>Muestra agrupamientos complejos entre estudiantes.</a:t>
-            </a:r>
-          </a:p>
-          <a:p>
+              <a:t>Muestra agrupamientos complejos y separaciones no lineales entre estudiantes.</a:t>
+            </a:r>
+          </a:p>
+          <a:p>
+            <a:pPr algn="just"/>
             <a:r>
               <a:rPr lang="es-MX" dirty="0"/>
               <a:t>Complementa la visualización obtenida con PCA.</a:t>
             </a:r>
+          </a:p>
+          <a:p>
+            <a:pPr algn="just"/>
+            <a:endParaRPr lang="es-MX" dirty="0"/>
+          </a:p>
+          <a:p>
+            <a:pPr marL="0" indent="0" algn="just">
+              <a:buNone/>
+            </a:pPr>
+            <a:r>
+              <a:rPr lang="es-MX" dirty="0"/>
+              <a:t>El PCA logró conservar aproximadamente el 94.8% de la variabilidad total utilizando únicamente dos componentes principales.</a:t>
+            </a:r>
             <a:endParaRPr lang="es-EC" dirty="0"/>
           </a:p>
         </p:txBody>
       </p:sp>
       <p:pic>
         <p:nvPicPr>
-          <p:cNvPr id="7" name="Imagen 6">
+          <p:cNvPr id="3" name="Imagen 2">
             <a:extLst>
               <a:ext uri="{FF2B5EF4-FFF2-40B4-BE49-F238E27FC236}">
-                <a16:creationId xmlns:a16="http://schemas.microsoft.com/office/drawing/2014/main" id="{3D251192-A214-2BF3-13E1-773BF7BBA8F1}"/>
+                <a16:creationId xmlns:a16="http://schemas.microsoft.com/office/drawing/2014/main" id="{3A87A990-5C63-8E31-706F-27A0ED31BC3B}"/>
               </a:ext>
             </a:extLst>
           </p:cNvPr>
@@ -11180,8 +11202,8 @@
         </p:blipFill>
         <p:spPr>
           <a:xfrm>
-            <a:off x="7656964" y="0"/>
-            <a:ext cx="4535036" cy="3401277"/>
+            <a:off x="7867808" y="3469270"/>
+            <a:ext cx="4324192" cy="3388729"/>
           </a:xfrm>
           <a:prstGeom prst="rect">
             <a:avLst/>
@@ -11190,10 +11212,10 @@
       </p:pic>
       <p:pic>
         <p:nvPicPr>
-          <p:cNvPr id="9" name="Imagen 8">
+          <p:cNvPr id="4" name="Imagen 3">
             <a:extLst>
               <a:ext uri="{FF2B5EF4-FFF2-40B4-BE49-F238E27FC236}">
-                <a16:creationId xmlns:a16="http://schemas.microsoft.com/office/drawing/2014/main" id="{B2D53A6B-6B8A-883B-88FC-163FD0F45B91}"/>
+                <a16:creationId xmlns:a16="http://schemas.microsoft.com/office/drawing/2014/main" id="{F9309C48-1A8D-E0DB-0989-92E84F28FA03}"/>
               </a:ext>
             </a:extLst>
           </p:cNvPr>
@@ -11210,8 +11232,8 @@
         </p:blipFill>
         <p:spPr>
           <a:xfrm>
-            <a:off x="7656964" y="3456723"/>
-            <a:ext cx="4535036" cy="3401277"/>
+            <a:off x="7867808" y="64021"/>
+            <a:ext cx="4324191" cy="3364979"/>
           </a:xfrm>
           <a:prstGeom prst="rect">
             <a:avLst/>
@@ -11299,7 +11321,7 @@
             <p:ph sz="half" idx="2"/>
             <p:extLst>
               <p:ext uri="{D42A27DB-BD31-4B8C-83A1-F6EECF244321}">
-                <p14:modId xmlns:p14="http://schemas.microsoft.com/office/powerpoint/2010/main" val="2607207841"/>
+                <p14:modId xmlns:p14="http://schemas.microsoft.com/office/powerpoint/2010/main" val="1150276446"/>
               </p:ext>
             </p:extLst>
           </p:nvPr>
@@ -11386,8 +11408,12 @@
                     <a:lstStyle/>
                     <a:p>
                       <a:r>
+                        <a:rPr lang="es-MX" dirty="0" err="1"/>
+                        <a:t>Clusters</a:t>
+                      </a:r>
+                      <a:r>
                         <a:rPr lang="es-MX" dirty="0"/>
-                        <a:t>Cluster más balanceados y fáciles de interpretar</a:t>
+                        <a:t> relativamente balanceados y fáciles de interpretar</a:t>
                       </a:r>
                       <a:endParaRPr lang="es-EC" dirty="0"/>
                     </a:p>
@@ -11457,7 +11483,7 @@
                     <a:p>
                       <a:r>
                         <a:rPr lang="es-MX" dirty="0"/>
-                        <a:t>Buena representación lineal de los datos</a:t>
+                        <a:t>Alta conservación de variabilidad en 2 dimensiones (~94.8%)</a:t>
                       </a:r>
                       <a:endParaRPr lang="es-EC" dirty="0"/>
                     </a:p>
@@ -11524,7 +11550,7 @@
         <p:spPr>
           <a:xfrm>
             <a:off x="667820" y="5095982"/>
-            <a:ext cx="10714178" cy="923330"/>
+            <a:ext cx="10714178" cy="1200329"/>
           </a:xfrm>
           <a:prstGeom prst="rect">
             <a:avLst/>
@@ -11547,15 +11573,7 @@
             <a:pPr algn="just"/>
             <a:r>
               <a:rPr lang="es-MX" dirty="0"/>
-              <a:t>K-Means presentó una segmentación más clara y consistente para este </a:t>
-            </a:r>
-            <a:r>
-              <a:rPr lang="es-MX" dirty="0" err="1"/>
-              <a:t>dataset</a:t>
-            </a:r>
-            <a:r>
-              <a:rPr lang="es-MX" dirty="0"/>
-              <a:t>, mientras que DBSCAN permitió detectar observaciones atípicas y agrupamientos menos uniformes.</a:t>
+              <a:t>K-Means permitió obtener una segmentación interpretable de los estudiantes, mientras que DBSCAN facilitó la detección de ruido y agrupamientos por densidad. PCA y t-SNE ayudaron a visualizar de manera más clara los patrones presentes en los datos.</a:t>
             </a:r>
             <a:endParaRPr lang="es-EC" dirty="0"/>
           </a:p>
@@ -12402,23 +12420,12 @@
 </file>
 
 <file path=customXml/item1.xml><?xml version="1.0" encoding="utf-8"?>
-<p:properties xmlns:p="http://schemas.microsoft.com/office/2006/metadata/properties" xmlns:xsi="http://www.w3.org/2001/XMLSchema-instance" xmlns:pc="http://schemas.microsoft.com/office/infopath/2007/PartnerControls">
-  <documentManagement>
-    <_ip_UnifiedCompliancePolicyUIAction xmlns="http://schemas.microsoft.com/sharepoint/v3" xsi:nil="true"/>
-    <Image xmlns="71af3243-3dd4-4a8d-8c0d-dd76da1f02a5">
-      <Url xsi:nil="true"/>
-      <Description xsi:nil="true"/>
-    </Image>
-    <Status xmlns="71af3243-3dd4-4a8d-8c0d-dd76da1f02a5">Not started</Status>
-    <Background xmlns="71af3243-3dd4-4a8d-8c0d-dd76da1f02a5">false</Background>
-    <_ip_UnifiedCompliancePolicyProperties xmlns="http://schemas.microsoft.com/sharepoint/v3" xsi:nil="true"/>
-    <ImageTagsTaxHTField xmlns="71af3243-3dd4-4a8d-8c0d-dd76da1f02a5">
-      <Terms xmlns="http://schemas.microsoft.com/office/infopath/2007/PartnerControls"/>
-    </ImageTagsTaxHTField>
-    <TaxCatchAll xmlns="230e9df3-be65-4c73-a93b-d1236ebd677e" xsi:nil="true"/>
-    <MediaServiceKeyPoints xmlns="71af3243-3dd4-4a8d-8c0d-dd76da1f02a5" xsi:nil="true"/>
-  </documentManagement>
-</p:properties>
+<?mso-contentType ?>
+<FormTemplates xmlns="http://schemas.microsoft.com/sharepoint/v3/contenttype/forms">
+  <Display>DocumentLibraryForm</Display>
+  <Edit>DocumentLibraryForm</Edit>
+  <New>DocumentLibraryForm</New>
+</FormTemplates>
 </file>
 
 <file path=customXml/item2.xml><?xml version="1.0" encoding="utf-8"?>
@@ -12710,22 +12717,29 @@
 </file>
 
 <file path=customXml/item3.xml><?xml version="1.0" encoding="utf-8"?>
-<?mso-contentType ?>
-<FormTemplates xmlns="http://schemas.microsoft.com/sharepoint/v3/contenttype/forms">
-  <Display>DocumentLibraryForm</Display>
-  <Edit>DocumentLibraryForm</Edit>
-  <New>DocumentLibraryForm</New>
-</FormTemplates>
+<p:properties xmlns:p="http://schemas.microsoft.com/office/2006/metadata/properties" xmlns:xsi="http://www.w3.org/2001/XMLSchema-instance" xmlns:pc="http://schemas.microsoft.com/office/infopath/2007/PartnerControls">
+  <documentManagement>
+    <_ip_UnifiedCompliancePolicyUIAction xmlns="http://schemas.microsoft.com/sharepoint/v3" xsi:nil="true"/>
+    <Image xmlns="71af3243-3dd4-4a8d-8c0d-dd76da1f02a5">
+      <Url xsi:nil="true"/>
+      <Description xsi:nil="true"/>
+    </Image>
+    <Status xmlns="71af3243-3dd4-4a8d-8c0d-dd76da1f02a5">Not started</Status>
+    <Background xmlns="71af3243-3dd4-4a8d-8c0d-dd76da1f02a5">false</Background>
+    <_ip_UnifiedCompliancePolicyProperties xmlns="http://schemas.microsoft.com/sharepoint/v3" xsi:nil="true"/>
+    <ImageTagsTaxHTField xmlns="71af3243-3dd4-4a8d-8c0d-dd76da1f02a5">
+      <Terms xmlns="http://schemas.microsoft.com/office/infopath/2007/PartnerControls"/>
+    </ImageTagsTaxHTField>
+    <TaxCatchAll xmlns="230e9df3-be65-4c73-a93b-d1236ebd677e" xsi:nil="true"/>
+    <MediaServiceKeyPoints xmlns="71af3243-3dd4-4a8d-8c0d-dd76da1f02a5" xsi:nil="true"/>
+  </documentManagement>
+</p:properties>
 </file>
 
 <file path=customXml/itemProps1.xml><?xml version="1.0" encoding="utf-8"?>
-<ds:datastoreItem xmlns:ds="http://schemas.openxmlformats.org/officeDocument/2006/customXml" ds:itemID="{BC8413E5-0484-489B-B293-D8720B6027F2}">
+<ds:datastoreItem xmlns:ds="http://schemas.openxmlformats.org/officeDocument/2006/customXml" ds:itemID="{019B3EA6-E2E1-4B68-B700-9432F9FC79DA}">
   <ds:schemaRefs>
-    <ds:schemaRef ds:uri="http://schemas.microsoft.com/office/2006/metadata/properties"/>
-    <ds:schemaRef ds:uri="http://schemas.microsoft.com/office/infopath/2007/PartnerControls"/>
-    <ds:schemaRef ds:uri="http://schemas.microsoft.com/sharepoint/v3"/>
-    <ds:schemaRef ds:uri="71af3243-3dd4-4a8d-8c0d-dd76da1f02a5"/>
-    <ds:schemaRef ds:uri="230e9df3-be65-4c73-a93b-d1236ebd677e"/>
+    <ds:schemaRef ds:uri="http://schemas.microsoft.com/sharepoint/v3/contenttype/forms"/>
   </ds:schemaRefs>
 </ds:datastoreItem>
 </file>
@@ -12752,9 +12766,13 @@
 </file>
 
 <file path=customXml/itemProps3.xml><?xml version="1.0" encoding="utf-8"?>
-<ds:datastoreItem xmlns:ds="http://schemas.openxmlformats.org/officeDocument/2006/customXml" ds:itemID="{019B3EA6-E2E1-4B68-B700-9432F9FC79DA}">
+<ds:datastoreItem xmlns:ds="http://schemas.openxmlformats.org/officeDocument/2006/customXml" ds:itemID="{BC8413E5-0484-489B-B293-D8720B6027F2}">
   <ds:schemaRefs>
-    <ds:schemaRef ds:uri="http://schemas.microsoft.com/sharepoint/v3/contenttype/forms"/>
+    <ds:schemaRef ds:uri="http://schemas.microsoft.com/office/2006/metadata/properties"/>
+    <ds:schemaRef ds:uri="http://schemas.microsoft.com/office/infopath/2007/PartnerControls"/>
+    <ds:schemaRef ds:uri="http://schemas.microsoft.com/sharepoint/v3"/>
+    <ds:schemaRef ds:uri="71af3243-3dd4-4a8d-8c0d-dd76da1f02a5"/>
+    <ds:schemaRef ds:uri="230e9df3-be65-4c73-a93b-d1236ebd677e"/>
   </ds:schemaRefs>
 </ds:datastoreItem>
 </file>
</xml_diff>